<commit_message>
Update presentation with team member photo on second slide
Add user's picture to the presentation on slide 2, replacing the placeholder image within the designated circle.

Replit-Commit-Author: Agent
Replit-Commit-Session-Id: d1af01ac-c843-4bff-a7a9-fedef4198273
Replit-Commit-Checkpoint-Type: full_checkpoint
Replit-Commit-Event-Id: ca7c8e5a-b0bb-4f41-93dd-99e03b3b65f8
Replit-Helium-Checkpoint-Created: true
</commit_message>
<xml_diff>
--- a/attached_assets/Cisco_Webex_Case_Comp_By_Agentix_Consulting_1772854922433.pptx
+++ b/attached_assets/Cisco_Webex_Case_Comp_By_Agentix_Consulting_1772854922433.pptx
@@ -10936,6 +10936,30 @@
           </a:p>
         </p:txBody>
       </p:sp>
+      <p:pic>
+        <p:nvPicPr>
+          <p:cNvPr id="20" name="Picture 19" descr="lana_circle.png"/>
+          <p:cNvPicPr>
+            <a:picLocks noChangeAspect="1"/>
+          </p:cNvPicPr>
+          <p:nvPr/>
+        </p:nvPicPr>
+        <p:blipFill>
+          <a:blip r:embed="rId5"/>
+          <a:stretch>
+            <a:fillRect/>
+          </a:stretch>
+        </p:blipFill>
+        <p:spPr>
+          <a:xfrm>
+            <a:off x="5365461" y="3710672"/>
+            <a:ext cx="2983924" cy="2983924"/>
+          </a:xfrm>
+          <a:prstGeom prst="rect">
+            <a:avLst/>
+          </a:prstGeom>
+        </p:spPr>
+      </p:pic>
     </p:spTree>
   </p:cSld>
   <p:clrMapOvr>

</xml_diff>